<commit_message>
Atualiza slides e analise com a medicao de 12 nucleos
</commit_message>
<xml_diff>
--- a/slides/apresentacao.pptx
+++ b/slides/apresentacao.pptx
@@ -2415,7 +2415,7 @@
                           <a:ea typeface="Calibri" pitchFamily="34" charset="-122"/>
                           <a:cs typeface="Calibri" pitchFamily="34" charset="-120"/>
                         </a:rPr>
-                        <a:t>0,198 s</a:t>
+                        <a:t>0,278 s</a:t>
                       </a:r>
                       <a:endParaRPr lang="en-US" sz="1100" dirty="0">
                         <a:latin typeface="Calibri" charset="0"/>
@@ -2480,7 +2480,7 @@
                           <a:ea typeface="Calibri" pitchFamily="34" charset="-122"/>
                           <a:cs typeface="Calibri" pitchFamily="34" charset="-120"/>
                         </a:rPr>
-                        <a:t>0,409 s</a:t>
+                        <a:t>0,575 s</a:t>
                       </a:r>
                       <a:endParaRPr lang="en-US" sz="1100" dirty="0">
                         <a:latin typeface="Calibri" charset="0"/>
@@ -2612,7 +2612,7 @@
                           <a:ea typeface="Calibri" pitchFamily="34" charset="-122"/>
                           <a:cs typeface="Calibri" pitchFamily="34" charset="-120"/>
                         </a:rPr>
-                        <a:t>0,295 s  (0,67x)</a:t>
+                        <a:t>0,441 s  (0,63x)</a:t>
                       </a:r>
                       <a:endParaRPr lang="en-US" sz="1100" dirty="0">
                         <a:latin typeface="Calibri" charset="0"/>
@@ -2677,7 +2677,7 @@
                           <a:ea typeface="Calibri" pitchFamily="34" charset="-122"/>
                           <a:cs typeface="Calibri" pitchFamily="34" charset="-120"/>
                         </a:rPr>
-                        <a:t>0,521 s  (0,78x)</a:t>
+                        <a:t>0,747 s  (0,77x)</a:t>
                       </a:r>
                       <a:endParaRPr lang="en-US" sz="1100" dirty="0">
                         <a:latin typeface="Calibri" charset="0"/>
@@ -2809,7 +2809,7 @@
                           <a:ea typeface="Calibri" pitchFamily="34" charset="-122"/>
                           <a:cs typeface="Calibri" pitchFamily="34" charset="-120"/>
                         </a:rPr>
-                        <a:t>0,166 s  (1,20x)</a:t>
+                        <a:t>0,256 s  (1,09x)</a:t>
                       </a:r>
                       <a:endParaRPr lang="en-US" sz="1100" dirty="0">
                         <a:latin typeface="Calibri" charset="0"/>
@@ -2874,7 +2874,7 @@
                           <a:ea typeface="Calibri" pitchFamily="34" charset="-122"/>
                           <a:cs typeface="Calibri" pitchFamily="34" charset="-120"/>
                         </a:rPr>
-                        <a:t>0,278 s  (1,47x)</a:t>
+                        <a:t>0,405 s  (1,42x)</a:t>
                       </a:r>
                       <a:endParaRPr lang="en-US" sz="1100" dirty="0">
                         <a:latin typeface="Calibri" charset="0"/>
@@ -3006,7 +3006,7 @@
                           <a:ea typeface="Calibri" pitchFamily="34" charset="-122"/>
                           <a:cs typeface="Calibri" pitchFamily="34" charset="-120"/>
                         </a:rPr>
-                        <a:t>0,102 s  (1,95x)</a:t>
+                        <a:t>0,180 s  (1,55x)</a:t>
                       </a:r>
                       <a:endParaRPr lang="en-US" sz="1100" dirty="0">
                         <a:latin typeface="Calibri" charset="0"/>
@@ -3071,7 +3071,7 @@
                           <a:ea typeface="Calibri" pitchFamily="34" charset="-122"/>
                           <a:cs typeface="Calibri" pitchFamily="34" charset="-120"/>
                         </a:rPr>
-                        <a:t>0,162 s  (2,53x)</a:t>
+                        <a:t>0,257 s  (2,24x)</a:t>
                       </a:r>
                       <a:endParaRPr lang="en-US" sz="1100" dirty="0">
                         <a:latin typeface="Calibri" charset="0"/>
@@ -3203,7 +3203,7 @@
                           <a:ea typeface="Calibri" pitchFamily="34" charset="-122"/>
                           <a:cs typeface="Calibri" pitchFamily="34" charset="-120"/>
                         </a:rPr>
-                        <a:t>0,078 s  (2,55x)</a:t>
+                        <a:t>0,118 s  (2,36x)</a:t>
                       </a:r>
                       <a:endParaRPr lang="en-US" sz="1100" dirty="0">
                         <a:latin typeface="Calibri" charset="0"/>
@@ -3268,7 +3268,7 @@
                           <a:ea typeface="Calibri" pitchFamily="34" charset="-122"/>
                           <a:cs typeface="Calibri" pitchFamily="34" charset="-120"/>
                         </a:rPr>
-                        <a:t>0,111 s  (3,68x)</a:t>
+                        <a:t>0,169 s  (3,41x)</a:t>
                       </a:r>
                       <a:endParaRPr lang="en-US" sz="1100" dirty="0">
                         <a:latin typeface="Calibri" charset="0"/>
@@ -3439,7 +3439,7 @@
                 <a:ea typeface="Calibri" pitchFamily="34" charset="-122"/>
                 <a:cs typeface="Calibri" pitchFamily="34" charset="-120"/>
               </a:rPr>
-              <a:t>Descontando esse custo estrutural, o ganho de 1 para 8 threads é de 3,79x na esparsa e 4,69x na densa.</a:t>
+              <a:t>Descontando esse custo estrutural, o ganho de 1 para 8 threads é de 3,74x na esparsa e 4,42x na densa.</a:t>
             </a:r>
             <a:endParaRPr lang="en-US" sz="1200" dirty="0"/>
           </a:p>
@@ -3460,7 +3460,7 @@
                 <a:ea typeface="Calibri" pitchFamily="34" charset="-122"/>
                 <a:cs typeface="Calibri" pitchFamily="34" charset="-120"/>
               </a:rPr>
-              <a:t>Matriz 200 x 200: com 8 threads a aceleração cai para 0,58, porque criar as threads custa mais que o trabalho.</a:t>
+              <a:t>Matriz 200 x 200: com 8 threads a aceleração cai para 0,30, porque criar as threads custa mais que o trabalho.</a:t>
             </a:r>
             <a:endParaRPr lang="en-US" sz="1200" dirty="0"/>
           </a:p>
@@ -3705,7 +3705,7 @@
                 <a:ea typeface="Calibri" pitchFamily="34" charset="-122"/>
                 <a:cs typeface="Calibri" pitchFamily="34" charset="-120"/>
               </a:rPr>
-              <a:t>0,0965 s</a:t>
+              <a:t>0,142 s</a:t>
             </a:r>
             <a:endParaRPr lang="en-US" sz="1300" dirty="0"/>
           </a:p>
@@ -3722,7 +3722,7 @@
                 <a:ea typeface="Calibri" pitchFamily="34" charset="-122"/>
                 <a:cs typeface="Calibri" pitchFamily="34" charset="-120"/>
               </a:rPr>
-              <a:t>95,5% do tempo</a:t>
+              <a:t>96,2% do tempo</a:t>
             </a:r>
             <a:endParaRPr lang="en-US" sz="1300" dirty="0"/>
           </a:p>
@@ -3825,7 +3825,7 @@
                 <a:ea typeface="Calibri" pitchFamily="34" charset="-122"/>
                 <a:cs typeface="Calibri" pitchFamily="34" charset="-120"/>
               </a:rPr>
-              <a:t>0,00053 s</a:t>
+              <a:t>0,0010 s</a:t>
             </a:r>
             <a:endParaRPr lang="en-US" sz="1300" dirty="0"/>
           </a:p>
@@ -3842,7 +3842,7 @@
                 <a:ea typeface="Calibri" pitchFamily="34" charset="-122"/>
                 <a:cs typeface="Calibri" pitchFamily="34" charset="-120"/>
               </a:rPr>
-              <a:t>0,5% — única região crítica</a:t>
+              <a:t>0,7% — única região crítica</a:t>
             </a:r>
             <a:endParaRPr lang="en-US" sz="1300" dirty="0"/>
           </a:p>
@@ -3945,7 +3945,7 @@
                 <a:ea typeface="Calibri" pitchFamily="34" charset="-122"/>
                 <a:cs typeface="Calibri" pitchFamily="34" charset="-120"/>
               </a:rPr>
-              <a:t>0,0040 s</a:t>
+              <a:t>0,0046 s</a:t>
             </a:r>
             <a:endParaRPr lang="en-US" sz="1300" dirty="0"/>
           </a:p>
@@ -3962,7 +3962,7 @@
                 <a:ea typeface="Calibri" pitchFamily="34" charset="-122"/>
                 <a:cs typeface="Calibri" pitchFamily="34" charset="-120"/>
               </a:rPr>
-              <a:t>4,0% do tempo</a:t>
+              <a:t>3,1% do tempo</a:t>
             </a:r>
             <a:endParaRPr lang="en-US" sz="1300" dirty="0"/>
           </a:p>
@@ -4005,7 +4005,7 @@
                 <a:ea typeface="Calibri" pitchFamily="34" charset="-122"/>
                 <a:cs typeface="Calibri" pitchFamily="34" charset="-120"/>
               </a:rPr>
-              <a:t>Carga esparsa, 4 threads. A fração sequencial de 4,0% dá um teto de Amdahl de 3,6x com 4 threads e 6,3x com 8.</a:t>
+              <a:t>Carga esparsa, 4 threads. A fração sequencial de 3,1% dá um teto de Amdahl de 3,7x com 4 threads e 6,6x com 8.</a:t>
             </a:r>
             <a:endParaRPr lang="en-US" sz="1300" dirty="0"/>
           </a:p>
@@ -4026,7 +4026,7 @@
                 <a:ea typeface="Calibri" pitchFamily="34" charset="-122"/>
                 <a:cs typeface="Calibri" pitchFamily="34" charset="-120"/>
               </a:rPr>
-              <a:t>Na carga densa há menos objetos, então a contagem final cai para 0,7% e o teto sobe para 7,6x — foi ela que escalou melhor (3,68x).</a:t>
+              <a:t>Na carga densa há menos objetos, então a contagem final cai para 0,6% e o teto sobe para 7,7x — foi ela que escalou melhor (3,41x).</a:t>
             </a:r>
             <a:endParaRPr lang="en-US" sz="1300" dirty="0"/>
           </a:p>
@@ -4337,7 +4337,7 @@
                 <a:ea typeface="Calibri" pitchFamily="34" charset="-122"/>
                 <a:cs typeface="Calibri" pitchFamily="34" charset="-120"/>
               </a:rPr>
-              <a:t>Aceleração de até 3,68x com 8 threads; o paralelismo só compensa em matrizes grandes, e o teto é dado pela fração sequencial e pela banda de memória.</a:t>
+              <a:t>Aceleração de até 3,41x com 8 threads; o paralelismo só compensa em matrizes grandes, e o teto é dado pela fração sequencial e pela banda de memória.</a:t>
             </a:r>
             <a:endParaRPr lang="en-US" sz="1500" dirty="0"/>
           </a:p>
@@ -7379,7 +7379,7 @@
                 <a:ea typeface="Calibri" pitchFamily="34" charset="-122"/>
                 <a:cs typeface="Calibri" pitchFamily="34" charset="-120"/>
               </a:rPr>
-              <a:t>Consolidação das fronteiras</a:t>
+              <a:t>Por que Pthreads e não processos</a:t>
             </a:r>
             <a:endParaRPr lang="en-US" sz="3000" dirty="0"/>
           </a:p>
@@ -7387,128 +7387,22 @@
       </p:sp>
       <p:sp>
         <p:nvSpPr>
-          <p:cNvPr id="3" name="Text 1"/>
-          <p:cNvSpPr txBox="1"/>
-          <p:nvPr/>
-        </p:nvSpPr>
-        <p:spPr>
-          <a:xfrm>
-            <a:off x="457200" y="1051560"/>
-            <a:ext cx="5120640" cy="3291840"/>
-          </a:xfrm>
-          <a:prstGeom prst="rect">
-            <a:avLst/>
-          </a:prstGeom>
-          <a:noFill/>
-          <a:ln/>
-        </p:spPr>
-        <p:txBody>
-          <a:bodyPr wrap="square" lIns="0" tIns="0" rIns="0" bIns="0" rtlCol="0" anchor="t"/>
-          <a:lstStyle/>
-          <a:p>
-            <a:pPr marL="342900" indent="-342900">
-              <a:spcAft>
-                <a:spcPts val="800"/>
-              </a:spcAft>
-              <a:buSzPct val="100000"/>
-              <a:buChar char="•"/>
-            </a:pPr>
-            <a:r>
-              <a:rPr lang="en-US" sz="1400" dirty="0">
-                <a:solidFill>
-                  <a:srgbClr val="212121"/>
-                </a:solidFill>
-                <a:latin typeface="Calibri" pitchFamily="34" charset="0"/>
-                <a:ea typeface="Calibri" pitchFamily="34" charset="-122"/>
-                <a:cs typeface="Calibri" pitchFamily="34" charset="-120"/>
-              </a:rPr>
-              <a:t>Para cada célula 1 na primeira linha da faixa, olham-se os três vizinhos da última linha da faixa de cima: diagonal esquerda, vertical e diagonal direita.</a:t>
-            </a:r>
-            <a:endParaRPr lang="en-US" sz="1400" dirty="0"/>
-          </a:p>
-          <a:p>
-            <a:pPr marL="342900" indent="-342900">
-              <a:spcAft>
-                <a:spcPts val="800"/>
-              </a:spcAft>
-              <a:buSzPct val="100000"/>
-              <a:buChar char="•"/>
-            </a:pPr>
-            <a:r>
-              <a:rPr lang="en-US" sz="1400" dirty="0">
-                <a:solidFill>
-                  <a:srgbClr val="212121"/>
-                </a:solidFill>
-                <a:latin typeface="Calibri" pitchFamily="34" charset="0"/>
-                <a:ea typeface="Calibri" pitchFamily="34" charset="-122"/>
-                <a:cs typeface="Calibri" pitchFamily="34" charset="-120"/>
-              </a:rPr>
-              <a:t>Union-find com compressão de caminho; a raiz é sempre o menor rótulo, o que torna o resultado independente da ordem das threads.</a:t>
-            </a:r>
-            <a:endParaRPr lang="en-US" sz="1400" dirty="0"/>
-          </a:p>
-          <a:p>
-            <a:pPr marL="342900" indent="-342900">
-              <a:spcAft>
-                <a:spcPts val="800"/>
-              </a:spcAft>
-              <a:buSzPct val="100000"/>
-              <a:buChar char="•"/>
-            </a:pPr>
-            <a:r>
-              <a:rPr lang="en-US" sz="1400" dirty="0">
-                <a:solidFill>
-                  <a:srgbClr val="212121"/>
-                </a:solidFill>
-                <a:latin typeface="Calibri" pitchFamily="34" charset="0"/>
-                <a:ea typeface="Calibri" pitchFamily="34" charset="-122"/>
-                <a:cs typeface="Calibri" pitchFamily="34" charset="-120"/>
-              </a:rPr>
-              <a:t>Cada união acontece entre pthread_mutex_lock e pthread_mutex_unlock: essa é a região crítica.</a:t>
-            </a:r>
-            <a:endParaRPr lang="en-US" sz="1400" dirty="0"/>
-          </a:p>
-          <a:p>
-            <a:pPr marL="342900" indent="-342900">
-              <a:spcAft>
-                <a:spcPts val="800"/>
-              </a:spcAft>
-              <a:buSzPct val="100000"/>
-              <a:buChar char="•"/>
-            </a:pPr>
-            <a:r>
-              <a:rPr lang="en-US" sz="1400" dirty="0">
-                <a:solidFill>
-                  <a:srgbClr val="212121"/>
-                </a:solidFill>
-                <a:latin typeface="Calibri" pitchFamily="34" charset="0"/>
-                <a:ea typeface="Calibri" pitchFamily="34" charset="-122"/>
-                <a:cs typeface="Calibri" pitchFamily="34" charset="-120"/>
-              </a:rPr>
-              <a:t>Cada thread trata só a sua fronteira superior, então nenhuma fronteira é feita duas vezes.</a:t>
-            </a:r>
-            <a:endParaRPr lang="en-US" sz="1400" dirty="0"/>
-          </a:p>
-        </p:txBody>
-      </p:sp>
-      <p:sp>
-        <p:nvSpPr>
-          <p:cNvPr id="4" name="Shape 2"/>
+          <p:cNvPr id="3" name="Shape 1"/>
           <p:cNvSpPr/>
           <p:nvPr/>
         </p:nvSpPr>
         <p:spPr>
           <a:xfrm>
-            <a:off x="5943600" y="1463040"/>
-            <a:ext cx="420624" cy="420624"/>
+            <a:off x="457200" y="1143000"/>
+            <a:ext cx="4023360" cy="1417320"/>
           </a:xfrm>
           <a:prstGeom prst="rect">
             <a:avLst/>
           </a:prstGeom>
           <a:solidFill>
-            <a:srgbClr val="FFFFFF"/>
+            <a:srgbClr val="F2F2F2"/>
           </a:solidFill>
-          <a:ln w="9525">
+          <a:ln w="12700">
             <a:solidFill>
               <a:srgbClr val="C9CEDB"/>
             </a:solidFill>
@@ -7518,22 +7412,100 @@
       </p:sp>
       <p:sp>
         <p:nvSpPr>
-          <p:cNvPr id="5" name="Shape 3"/>
+          <p:cNvPr id="4" name="Text 2"/>
+          <p:cNvSpPr txBox="1"/>
+          <p:nvPr/>
+        </p:nvSpPr>
+        <p:spPr>
+          <a:xfrm>
+            <a:off x="621792" y="1252728"/>
+            <a:ext cx="3694176" cy="274320"/>
+          </a:xfrm>
+          <a:prstGeom prst="rect">
+            <a:avLst/>
+          </a:prstGeom>
+          <a:noFill/>
+          <a:ln/>
+        </p:spPr>
+        <p:txBody>
+          <a:bodyPr wrap="square" lIns="0" tIns="0" rIns="0" bIns="0" rtlCol="0" anchor="ctr"/>
+          <a:lstStyle/>
+          <a:p>
+            <a:pPr indent="0" marL="0">
+              <a:buNone/>
+            </a:pPr>
+            <a:r>
+              <a:rPr lang="en-US" sz="1500" b="1" dirty="0">
+                <a:solidFill>
+                  <a:srgbClr val="1E2761"/>
+                </a:solidFill>
+                <a:latin typeface="Calibri" pitchFamily="34" charset="0"/>
+                <a:ea typeface="Calibri" pitchFamily="34" charset="-122"/>
+                <a:cs typeface="Calibri" pitchFamily="34" charset="-120"/>
+              </a:rPr>
+              <a:t>Custo de criação</a:t>
+            </a:r>
+            <a:endParaRPr lang="en-US" sz="1500" dirty="0"/>
+          </a:p>
+        </p:txBody>
+      </p:sp>
+      <p:sp>
+        <p:nvSpPr>
+          <p:cNvPr id="5" name="Text 3"/>
+          <p:cNvSpPr txBox="1"/>
+          <p:nvPr/>
+        </p:nvSpPr>
+        <p:spPr>
+          <a:xfrm>
+            <a:off x="621792" y="1581912"/>
+            <a:ext cx="3694176" cy="868680"/>
+          </a:xfrm>
+          <a:prstGeom prst="rect">
+            <a:avLst/>
+          </a:prstGeom>
+          <a:noFill/>
+          <a:ln/>
+        </p:spPr>
+        <p:txBody>
+          <a:bodyPr wrap="square" lIns="0" tIns="0" rIns="0" bIns="0" rtlCol="0" anchor="t"/>
+          <a:lstStyle/>
+          <a:p>
+            <a:pPr indent="0" marL="0">
+              <a:buNone/>
+            </a:pPr>
+            <a:r>
+              <a:rPr lang="en-US" sz="1300" dirty="0">
+                <a:solidFill>
+                  <a:srgbClr val="212121"/>
+                </a:solidFill>
+                <a:latin typeface="Calibri" pitchFamily="34" charset="0"/>
+                <a:ea typeface="Calibri" pitchFamily="34" charset="-122"/>
+                <a:cs typeface="Calibri" pitchFamily="34" charset="-120"/>
+              </a:rPr>
+              <a:t>A medição do material da disciplina: fork() custa cerca de 4x mais que pthread_create(), porque exige montar uma nova tabela de páginas.</a:t>
+            </a:r>
+            <a:endParaRPr lang="en-US" sz="1300" dirty="0"/>
+          </a:p>
+        </p:txBody>
+      </p:sp>
+      <p:sp>
+        <p:nvSpPr>
+          <p:cNvPr id="6" name="Shape 4"/>
           <p:cNvSpPr/>
           <p:nvPr/>
         </p:nvSpPr>
         <p:spPr>
           <a:xfrm>
-            <a:off x="6364224" y="1463040"/>
-            <a:ext cx="420624" cy="420624"/>
+            <a:off x="4663440" y="1143000"/>
+            <a:ext cx="4023360" cy="1417320"/>
           </a:xfrm>
           <a:prstGeom prst="rect">
             <a:avLst/>
           </a:prstGeom>
           <a:solidFill>
-            <a:srgbClr val="97BC62"/>
+            <a:srgbClr val="F2F2F2"/>
           </a:solidFill>
-          <a:ln w="9525">
+          <a:ln w="12700">
             <a:solidFill>
               <a:srgbClr val="C9CEDB"/>
             </a:solidFill>
@@ -7543,22 +7515,100 @@
       </p:sp>
       <p:sp>
         <p:nvSpPr>
-          <p:cNvPr id="6" name="Shape 4"/>
+          <p:cNvPr id="7" name="Text 5"/>
+          <p:cNvSpPr txBox="1"/>
+          <p:nvPr/>
+        </p:nvSpPr>
+        <p:spPr>
+          <a:xfrm>
+            <a:off x="4828032" y="1252728"/>
+            <a:ext cx="3694176" cy="274320"/>
+          </a:xfrm>
+          <a:prstGeom prst="rect">
+            <a:avLst/>
+          </a:prstGeom>
+          <a:noFill/>
+          <a:ln/>
+        </p:spPr>
+        <p:txBody>
+          <a:bodyPr wrap="square" lIns="0" tIns="0" rIns="0" bIns="0" rtlCol="0" anchor="ctr"/>
+          <a:lstStyle/>
+          <a:p>
+            <a:pPr indent="0" marL="0">
+              <a:buNone/>
+            </a:pPr>
+            <a:r>
+              <a:rPr lang="en-US" sz="1500" b="1" dirty="0">
+                <a:solidFill>
+                  <a:srgbClr val="1E2761"/>
+                </a:solidFill>
+                <a:latin typeface="Calibri" pitchFamily="34" charset="0"/>
+                <a:ea typeface="Calibri" pitchFamily="34" charset="-122"/>
+                <a:cs typeface="Calibri" pitchFamily="34" charset="-120"/>
+              </a:rPr>
+              <a:t>Natureza dos dados</a:t>
+            </a:r>
+            <a:endParaRPr lang="en-US" sz="1500" dirty="0"/>
+          </a:p>
+        </p:txBody>
+      </p:sp>
+      <p:sp>
+        <p:nvSpPr>
+          <p:cNvPr id="8" name="Text 6"/>
+          <p:cNvSpPr txBox="1"/>
+          <p:nvPr/>
+        </p:nvSpPr>
+        <p:spPr>
+          <a:xfrm>
+            <a:off x="4828032" y="1581912"/>
+            <a:ext cx="3694176" cy="868680"/>
+          </a:xfrm>
+          <a:prstGeom prst="rect">
+            <a:avLst/>
+          </a:prstGeom>
+          <a:noFill/>
+          <a:ln/>
+        </p:spPr>
+        <p:txBody>
+          <a:bodyPr wrap="square" lIns="0" tIns="0" rIns="0" bIns="0" rtlCol="0" anchor="t"/>
+          <a:lstStyle/>
+          <a:p>
+            <a:pPr indent="0" marL="0">
+              <a:buNone/>
+            </a:pPr>
+            <a:r>
+              <a:rPr lang="en-US" sz="1300" dirty="0">
+                <a:solidFill>
+                  <a:srgbClr val="212121"/>
+                </a:solidFill>
+                <a:latin typeface="Calibri" pitchFamily="34" charset="0"/>
+                <a:ea typeface="Calibri" pitchFamily="34" charset="-122"/>
+                <a:cs typeface="Calibri" pitchFamily="34" charset="-120"/>
+              </a:rPr>
+              <a:t>A matriz e o vetor de rótulos são grandes e precisam ser vistos por todos. Com threads eles já são compartilhados.</a:t>
+            </a:r>
+            <a:endParaRPr lang="en-US" sz="1300" dirty="0"/>
+          </a:p>
+        </p:txBody>
+      </p:sp>
+      <p:sp>
+        <p:nvSpPr>
+          <p:cNvPr id="9" name="Shape 7"/>
           <p:cNvSpPr/>
           <p:nvPr/>
         </p:nvSpPr>
         <p:spPr>
           <a:xfrm>
-            <a:off x="6784848" y="1463040"/>
-            <a:ext cx="420624" cy="420624"/>
+            <a:off x="457200" y="2743200"/>
+            <a:ext cx="4023360" cy="1280160"/>
           </a:xfrm>
           <a:prstGeom prst="rect">
             <a:avLst/>
           </a:prstGeom>
           <a:solidFill>
-            <a:srgbClr val="97BC62"/>
+            <a:srgbClr val="F2F2F2"/>
           </a:solidFill>
-          <a:ln w="9525">
+          <a:ln w="12700">
             <a:solidFill>
               <a:srgbClr val="C9CEDB"/>
             </a:solidFill>
@@ -7568,22 +7618,100 @@
       </p:sp>
       <p:sp>
         <p:nvSpPr>
-          <p:cNvPr id="7" name="Shape 5"/>
+          <p:cNvPr id="10" name="Text 8"/>
+          <p:cNvSpPr txBox="1"/>
+          <p:nvPr/>
+        </p:nvSpPr>
+        <p:spPr>
+          <a:xfrm>
+            <a:off x="621792" y="2852928"/>
+            <a:ext cx="3694176" cy="274320"/>
+          </a:xfrm>
+          <a:prstGeom prst="rect">
+            <a:avLst/>
+          </a:prstGeom>
+          <a:noFill/>
+          <a:ln/>
+        </p:spPr>
+        <p:txBody>
+          <a:bodyPr wrap="square" lIns="0" tIns="0" rIns="0" bIns="0" rtlCol="0" anchor="ctr"/>
+          <a:lstStyle/>
+          <a:p>
+            <a:pPr indent="0" marL="0">
+              <a:buNone/>
+            </a:pPr>
+            <a:r>
+              <a:rPr lang="en-US" sz="1500" b="1" dirty="0">
+                <a:solidFill>
+                  <a:srgbClr val="1E2761"/>
+                </a:solidFill>
+                <a:latin typeface="Calibri" pitchFamily="34" charset="0"/>
+                <a:ea typeface="Calibri" pitchFamily="34" charset="-122"/>
+                <a:cs typeface="Calibri" pitchFamily="34" charset="-120"/>
+              </a:rPr>
+              <a:t>Com processos seria preciso</a:t>
+            </a:r>
+            <a:endParaRPr lang="en-US" sz="1500" dirty="0"/>
+          </a:p>
+        </p:txBody>
+      </p:sp>
+      <p:sp>
+        <p:nvSpPr>
+          <p:cNvPr id="11" name="Text 9"/>
+          <p:cNvSpPr txBox="1"/>
+          <p:nvPr/>
+        </p:nvSpPr>
+        <p:spPr>
+          <a:xfrm>
+            <a:off x="621792" y="3182112"/>
+            <a:ext cx="3694176" cy="731520"/>
+          </a:xfrm>
+          <a:prstGeom prst="rect">
+            <a:avLst/>
+          </a:prstGeom>
+          <a:noFill/>
+          <a:ln/>
+        </p:spPr>
+        <p:txBody>
+          <a:bodyPr wrap="square" lIns="0" tIns="0" rIns="0" bIns="0" rtlCol="0" anchor="t"/>
+          <a:lstStyle/>
+          <a:p>
+            <a:pPr indent="0" marL="0">
+              <a:buNone/>
+            </a:pPr>
+            <a:r>
+              <a:rPr lang="en-US" sz="1300" dirty="0">
+                <a:solidFill>
+                  <a:srgbClr val="212121"/>
+                </a:solidFill>
+                <a:latin typeface="Calibri" pitchFamily="34" charset="0"/>
+                <a:ea typeface="Calibri" pitchFamily="34" charset="-122"/>
+                <a:cs typeface="Calibri" pitchFamily="34" charset="-120"/>
+              </a:rPr>
+              <a:t>shm_open mais mmap, ou devolver resultados parciais por pipes: mais código, sem mais paralelismo.</a:t>
+            </a:r>
+            <a:endParaRPr lang="en-US" sz="1300" dirty="0"/>
+          </a:p>
+        </p:txBody>
+      </p:sp>
+      <p:sp>
+        <p:nvSpPr>
+          <p:cNvPr id="12" name="Shape 10"/>
           <p:cNvSpPr/>
           <p:nvPr/>
         </p:nvSpPr>
         <p:spPr>
           <a:xfrm>
-            <a:off x="7205472" y="1463040"/>
-            <a:ext cx="420624" cy="420624"/>
+            <a:off x="4663440" y="2743200"/>
+            <a:ext cx="4023360" cy="1280160"/>
           </a:xfrm>
           <a:prstGeom prst="rect">
             <a:avLst/>
           </a:prstGeom>
           <a:solidFill>
-            <a:srgbClr val="97BC62"/>
+            <a:srgbClr val="F2F2F2"/>
           </a:solidFill>
-          <a:ln w="9525">
+          <a:ln w="12700">
             <a:solidFill>
               <a:srgbClr val="C9CEDB"/>
             </a:solidFill>
@@ -7593,187 +7721,14 @@
       </p:sp>
       <p:sp>
         <p:nvSpPr>
-          <p:cNvPr id="8" name="Shape 6"/>
-          <p:cNvSpPr/>
-          <p:nvPr/>
-        </p:nvSpPr>
-        <p:spPr>
-          <a:xfrm>
-            <a:off x="7626096" y="1463040"/>
-            <a:ext cx="420624" cy="420624"/>
-          </a:xfrm>
-          <a:prstGeom prst="rect">
-            <a:avLst/>
-          </a:prstGeom>
-          <a:solidFill>
-            <a:srgbClr val="FFFFFF"/>
-          </a:solidFill>
-          <a:ln w="9525">
-            <a:solidFill>
-              <a:srgbClr val="C9CEDB"/>
-            </a:solidFill>
-            <a:prstDash val="solid"/>
-          </a:ln>
-        </p:spPr>
-      </p:sp>
-      <p:sp>
-        <p:nvSpPr>
-          <p:cNvPr id="9" name="Shape 7"/>
-          <p:cNvSpPr/>
-          <p:nvPr/>
-        </p:nvSpPr>
-        <p:spPr>
-          <a:xfrm>
-            <a:off x="5943600" y="1883664"/>
-            <a:ext cx="420624" cy="420624"/>
-          </a:xfrm>
-          <a:prstGeom prst="rect">
-            <a:avLst/>
-          </a:prstGeom>
-          <a:solidFill>
-            <a:srgbClr val="FFFFFF"/>
-          </a:solidFill>
-          <a:ln w="9525">
-            <a:solidFill>
-              <a:srgbClr val="C9CEDB"/>
-            </a:solidFill>
-            <a:prstDash val="solid"/>
-          </a:ln>
-        </p:spPr>
-      </p:sp>
-      <p:sp>
-        <p:nvSpPr>
-          <p:cNvPr id="10" name="Shape 8"/>
-          <p:cNvSpPr/>
-          <p:nvPr/>
-        </p:nvSpPr>
-        <p:spPr>
-          <a:xfrm>
-            <a:off x="6364224" y="1883664"/>
-            <a:ext cx="420624" cy="420624"/>
-          </a:xfrm>
-          <a:prstGeom prst="rect">
-            <a:avLst/>
-          </a:prstGeom>
-          <a:solidFill>
-            <a:srgbClr val="FFFFFF"/>
-          </a:solidFill>
-          <a:ln w="9525">
-            <a:solidFill>
-              <a:srgbClr val="C9CEDB"/>
-            </a:solidFill>
-            <a:prstDash val="solid"/>
-          </a:ln>
-        </p:spPr>
-      </p:sp>
-      <p:sp>
-        <p:nvSpPr>
-          <p:cNvPr id="11" name="Shape 9"/>
-          <p:cNvSpPr/>
-          <p:nvPr/>
-        </p:nvSpPr>
-        <p:spPr>
-          <a:xfrm>
-            <a:off x="6784848" y="1883664"/>
-            <a:ext cx="420624" cy="420624"/>
-          </a:xfrm>
-          <a:prstGeom prst="rect">
-            <a:avLst/>
-          </a:prstGeom>
-          <a:solidFill>
-            <a:srgbClr val="1E2761"/>
-          </a:solidFill>
-          <a:ln w="9525">
-            <a:solidFill>
-              <a:srgbClr val="C9CEDB"/>
-            </a:solidFill>
-            <a:prstDash val="solid"/>
-          </a:ln>
-        </p:spPr>
-      </p:sp>
-      <p:sp>
-        <p:nvSpPr>
-          <p:cNvPr id="12" name="Shape 10"/>
-          <p:cNvSpPr/>
-          <p:nvPr/>
-        </p:nvSpPr>
-        <p:spPr>
-          <a:xfrm>
-            <a:off x="7205472" y="1883664"/>
-            <a:ext cx="420624" cy="420624"/>
-          </a:xfrm>
-          <a:prstGeom prst="rect">
-            <a:avLst/>
-          </a:prstGeom>
-          <a:solidFill>
-            <a:srgbClr val="FFFFFF"/>
-          </a:solidFill>
-          <a:ln w="9525">
-            <a:solidFill>
-              <a:srgbClr val="C9CEDB"/>
-            </a:solidFill>
-            <a:prstDash val="solid"/>
-          </a:ln>
-        </p:spPr>
-      </p:sp>
-      <p:sp>
-        <p:nvSpPr>
-          <p:cNvPr id="13" name="Shape 11"/>
-          <p:cNvSpPr/>
-          <p:nvPr/>
-        </p:nvSpPr>
-        <p:spPr>
-          <a:xfrm>
-            <a:off x="7626096" y="1883664"/>
-            <a:ext cx="420624" cy="420624"/>
-          </a:xfrm>
-          <a:prstGeom prst="rect">
-            <a:avLst/>
-          </a:prstGeom>
-          <a:solidFill>
-            <a:srgbClr val="FFFFFF"/>
-          </a:solidFill>
-          <a:ln w="9525">
-            <a:solidFill>
-              <a:srgbClr val="C9CEDB"/>
-            </a:solidFill>
-            <a:prstDash val="solid"/>
-          </a:ln>
-        </p:spPr>
-      </p:sp>
-      <p:sp>
-        <p:nvSpPr>
-          <p:cNvPr id="14" name="Shape 12"/>
-          <p:cNvSpPr/>
-          <p:nvPr/>
-        </p:nvSpPr>
-        <p:spPr>
-          <a:xfrm>
-            <a:off x="5852160" y="1883664"/>
-            <a:ext cx="2286000" cy="0"/>
-          </a:xfrm>
-          <a:prstGeom prst="line">
-            <a:avLst/>
-          </a:prstGeom>
-          <a:noFill/>
-          <a:ln w="25400">
-            <a:solidFill>
-              <a:srgbClr val="B85042"/>
-            </a:solidFill>
-            <a:prstDash val="dash"/>
-          </a:ln>
-        </p:spPr>
-      </p:sp>
-      <p:sp>
-        <p:nvSpPr>
-          <p:cNvPr id="15" name="Text 13"/>
+          <p:cNvPr id="13" name="Text 11"/>
           <p:cNvSpPr txBox="1"/>
           <p:nvPr/>
         </p:nvSpPr>
         <p:spPr>
           <a:xfrm>
-            <a:off x="5394960" y="2423160"/>
-            <a:ext cx="3291840" cy="274320"/>
+            <a:off x="4828032" y="2852928"/>
+            <a:ext cx="3694176" cy="274320"/>
           </a:xfrm>
           <a:prstGeom prst="rect">
             <a:avLst/>
@@ -7785,34 +7740,73 @@
           <a:bodyPr wrap="square" lIns="0" tIns="0" rIns="0" bIns="0" rtlCol="0" anchor="ctr"/>
           <a:lstStyle/>
           <a:p>
-            <a:pPr algn="ctr" indent="0" marL="0">
+            <a:pPr indent="0" marL="0">
               <a:buNone/>
             </a:pPr>
             <a:r>
-              <a:rPr lang="en-US" sz="1200" dirty="0">
-                <a:solidFill>
-                  <a:srgbClr val="5A5A5A"/>
-                </a:solidFill>
-                <a:latin typeface="Calibri" pitchFamily="34" charset="0"/>
-                <a:ea typeface="Calibri" pitchFamily="34" charset="-122"/>
-                <a:cs typeface="Calibri" pitchFamily="34" charset="-120"/>
-              </a:rPr>
-              <a:t>fronteira entre duas faixas</a:t>
-            </a:r>
-            <a:endParaRPr lang="en-US" sz="1200" dirty="0"/>
+              <a:rPr lang="en-US" sz="1500" b="1" dirty="0">
+                <a:solidFill>
+                  <a:srgbClr val="1E2761"/>
+                </a:solidFill>
+                <a:latin typeface="Calibri" pitchFamily="34" charset="0"/>
+                <a:ea typeface="Calibri" pitchFamily="34" charset="-122"/>
+                <a:cs typeface="Calibri" pitchFamily="34" charset="-120"/>
+              </a:rPr>
+              <a:t>Cuidado conhecido</a:t>
+            </a:r>
+            <a:endParaRPr lang="en-US" sz="1500" dirty="0"/>
           </a:p>
         </p:txBody>
       </p:sp>
       <p:sp>
         <p:nvSpPr>
-          <p:cNvPr id="16" name="Text 14"/>
+          <p:cNvPr id="14" name="Text 12"/>
           <p:cNvSpPr txBox="1"/>
           <p:nvPr/>
         </p:nvSpPr>
         <p:spPr>
           <a:xfrm>
-            <a:off x="5394960" y="2743200"/>
-            <a:ext cx="3291840" cy="548640"/>
+            <a:off x="4828032" y="3182112"/>
+            <a:ext cx="3694176" cy="731520"/>
+          </a:xfrm>
+          <a:prstGeom prst="rect">
+            <a:avLst/>
+          </a:prstGeom>
+          <a:noFill/>
+          <a:ln/>
+        </p:spPr>
+        <p:txBody>
+          <a:bodyPr wrap="square" lIns="0" tIns="0" rIns="0" bIns="0" rtlCol="0" anchor="t"/>
+          <a:lstStyle/>
+          <a:p>
+            <a:pPr indent="0" marL="0">
+              <a:buNone/>
+            </a:pPr>
+            <a:r>
+              <a:rPr lang="en-US" sz="1300" dirty="0">
+                <a:solidFill>
+                  <a:srgbClr val="212121"/>
+                </a:solidFill>
+                <a:latin typeface="Calibri" pitchFamily="34" charset="0"/>
+                <a:ea typeface="Calibri" pitchFamily="34" charset="-122"/>
+                <a:cs typeface="Calibri" pitchFamily="34" charset="-120"/>
+              </a:rPr>
+              <a:t>fork() depois de criar threads clona mutexes travados. Aqui não há mistura dos dois modelos.</a:t>
+            </a:r>
+            <a:endParaRPr lang="en-US" sz="1300" dirty="0"/>
+          </a:p>
+        </p:txBody>
+      </p:sp>
+      <p:sp>
+        <p:nvSpPr>
+          <p:cNvPr id="15" name="Text 13"/>
+          <p:cNvSpPr txBox="1"/>
+          <p:nvPr/>
+        </p:nvSpPr>
+        <p:spPr>
+          <a:xfrm>
+            <a:off x="457200" y="4709160"/>
+            <a:ext cx="5486400" cy="274320"/>
           </a:xfrm>
           <a:prstGeom prst="rect">
             <a:avLst/>
@@ -7824,62 +7818,6 @@
           <a:bodyPr wrap="square" lIns="0" tIns="0" rIns="0" bIns="0" rtlCol="0" anchor="ctr"/>
           <a:lstStyle/>
           <a:p>
-            <a:pPr algn="ctr" indent="0" marL="0">
-              <a:buNone/>
-            </a:pPr>
-            <a:r>
-              <a:rPr lang="en-US" sz="1200" dirty="0">
-                <a:solidFill>
-                  <a:srgbClr val="212121"/>
-                </a:solidFill>
-                <a:latin typeface="Calibri" pitchFamily="34" charset="0"/>
-                <a:ea typeface="Calibri" pitchFamily="34" charset="-122"/>
-                <a:cs typeface="Calibri" pitchFamily="34" charset="-120"/>
-              </a:rPr>
-              <a:t>os três vizinhos cobrem a vertical</a:t>
-            </a:r>
-            <a:endParaRPr lang="en-US" sz="1200" dirty="0"/>
-          </a:p>
-          <a:p>
-            <a:pPr algn="ctr" indent="0" marL="0">
-              <a:buNone/>
-            </a:pPr>
-            <a:r>
-              <a:rPr lang="en-US" sz="1200" dirty="0">
-                <a:solidFill>
-                  <a:srgbClr val="212121"/>
-                </a:solidFill>
-                <a:latin typeface="Calibri" pitchFamily="34" charset="0"/>
-                <a:ea typeface="Calibri" pitchFamily="34" charset="-122"/>
-                <a:cs typeface="Calibri" pitchFamily="34" charset="-120"/>
-              </a:rPr>
-              <a:t>e as duas diagonais</a:t>
-            </a:r>
-            <a:endParaRPr lang="en-US" sz="1200" dirty="0"/>
-          </a:p>
-        </p:txBody>
-      </p:sp>
-      <p:sp>
-        <p:nvSpPr>
-          <p:cNvPr id="17" name="Text 15"/>
-          <p:cNvSpPr txBox="1"/>
-          <p:nvPr/>
-        </p:nvSpPr>
-        <p:spPr>
-          <a:xfrm>
-            <a:off x="457200" y="4709160"/>
-            <a:ext cx="5486400" cy="274320"/>
-          </a:xfrm>
-          <a:prstGeom prst="rect">
-            <a:avLst/>
-          </a:prstGeom>
-          <a:noFill/>
-          <a:ln/>
-        </p:spPr>
-        <p:txBody>
-          <a:bodyPr wrap="square" lIns="0" tIns="0" rIns="0" bIns="0" rtlCol="0" anchor="ctr"/>
-          <a:lstStyle/>
-          <a:p>
             <a:pPr indent="0" marL="0">
               <a:buNone/>
             </a:pPr>
@@ -7900,7 +7838,7 @@
       </p:sp>
       <p:sp>
         <p:nvSpPr>
-          <p:cNvPr id="18" name="Text 16"/>
+          <p:cNvPr id="16" name="Text 14"/>
           <p:cNvSpPr txBox="1"/>
           <p:nvPr/>
         </p:nvSpPr>
@@ -7995,7 +7933,7 @@
                 <a:ea typeface="Calibri" pitchFamily="34" charset="-122"/>
                 <a:cs typeface="Calibri" pitchFamily="34" charset="-120"/>
               </a:rPr>
-              <a:t>Por que Pthreads e não processos</a:t>
+              <a:t>Consolidação das fronteiras</a:t>
             </a:r>
             <a:endParaRPr lang="en-US" sz="3000" dirty="0"/>
           </a:p>
@@ -8003,22 +7941,128 @@
       </p:sp>
       <p:sp>
         <p:nvSpPr>
-          <p:cNvPr id="3" name="Shape 1"/>
+          <p:cNvPr id="3" name="Text 1"/>
+          <p:cNvSpPr txBox="1"/>
+          <p:nvPr/>
+        </p:nvSpPr>
+        <p:spPr>
+          <a:xfrm>
+            <a:off x="457200" y="1051560"/>
+            <a:ext cx="5120640" cy="3291840"/>
+          </a:xfrm>
+          <a:prstGeom prst="rect">
+            <a:avLst/>
+          </a:prstGeom>
+          <a:noFill/>
+          <a:ln/>
+        </p:spPr>
+        <p:txBody>
+          <a:bodyPr wrap="square" lIns="0" tIns="0" rIns="0" bIns="0" rtlCol="0" anchor="t"/>
+          <a:lstStyle/>
+          <a:p>
+            <a:pPr marL="342900" indent="-342900">
+              <a:spcAft>
+                <a:spcPts val="800"/>
+              </a:spcAft>
+              <a:buSzPct val="100000"/>
+              <a:buChar char="•"/>
+            </a:pPr>
+            <a:r>
+              <a:rPr lang="en-US" sz="1400" dirty="0">
+                <a:solidFill>
+                  <a:srgbClr val="212121"/>
+                </a:solidFill>
+                <a:latin typeface="Calibri" pitchFamily="34" charset="0"/>
+                <a:ea typeface="Calibri" pitchFamily="34" charset="-122"/>
+                <a:cs typeface="Calibri" pitchFamily="34" charset="-120"/>
+              </a:rPr>
+              <a:t>Para cada célula 1 na primeira linha da faixa, olham-se os três vizinhos da última linha da faixa de cima: diagonal esquerda, vertical e diagonal direita.</a:t>
+            </a:r>
+            <a:endParaRPr lang="en-US" sz="1400" dirty="0"/>
+          </a:p>
+          <a:p>
+            <a:pPr marL="342900" indent="-342900">
+              <a:spcAft>
+                <a:spcPts val="800"/>
+              </a:spcAft>
+              <a:buSzPct val="100000"/>
+              <a:buChar char="•"/>
+            </a:pPr>
+            <a:r>
+              <a:rPr lang="en-US" sz="1400" dirty="0">
+                <a:solidFill>
+                  <a:srgbClr val="212121"/>
+                </a:solidFill>
+                <a:latin typeface="Calibri" pitchFamily="34" charset="0"/>
+                <a:ea typeface="Calibri" pitchFamily="34" charset="-122"/>
+                <a:cs typeface="Calibri" pitchFamily="34" charset="-120"/>
+              </a:rPr>
+              <a:t>Union-find com compressão de caminho; a raiz é sempre o menor rótulo, o que torna o resultado independente da ordem das threads.</a:t>
+            </a:r>
+            <a:endParaRPr lang="en-US" sz="1400" dirty="0"/>
+          </a:p>
+          <a:p>
+            <a:pPr marL="342900" indent="-342900">
+              <a:spcAft>
+                <a:spcPts val="800"/>
+              </a:spcAft>
+              <a:buSzPct val="100000"/>
+              <a:buChar char="•"/>
+            </a:pPr>
+            <a:r>
+              <a:rPr lang="en-US" sz="1400" dirty="0">
+                <a:solidFill>
+                  <a:srgbClr val="212121"/>
+                </a:solidFill>
+                <a:latin typeface="Calibri" pitchFamily="34" charset="0"/>
+                <a:ea typeface="Calibri" pitchFamily="34" charset="-122"/>
+                <a:cs typeface="Calibri" pitchFamily="34" charset="-120"/>
+              </a:rPr>
+              <a:t>Cada união acontece entre pthread_mutex_lock e pthread_mutex_unlock: essa é a região crítica.</a:t>
+            </a:r>
+            <a:endParaRPr lang="en-US" sz="1400" dirty="0"/>
+          </a:p>
+          <a:p>
+            <a:pPr marL="342900" indent="-342900">
+              <a:spcAft>
+                <a:spcPts val="800"/>
+              </a:spcAft>
+              <a:buSzPct val="100000"/>
+              <a:buChar char="•"/>
+            </a:pPr>
+            <a:r>
+              <a:rPr lang="en-US" sz="1400" dirty="0">
+                <a:solidFill>
+                  <a:srgbClr val="212121"/>
+                </a:solidFill>
+                <a:latin typeface="Calibri" pitchFamily="34" charset="0"/>
+                <a:ea typeface="Calibri" pitchFamily="34" charset="-122"/>
+                <a:cs typeface="Calibri" pitchFamily="34" charset="-120"/>
+              </a:rPr>
+              <a:t>Cada thread trata só a sua fronteira superior, então nenhuma fronteira é feita duas vezes.</a:t>
+            </a:r>
+            <a:endParaRPr lang="en-US" sz="1400" dirty="0"/>
+          </a:p>
+        </p:txBody>
+      </p:sp>
+      <p:sp>
+        <p:nvSpPr>
+          <p:cNvPr id="4" name="Shape 2"/>
           <p:cNvSpPr/>
           <p:nvPr/>
         </p:nvSpPr>
         <p:spPr>
           <a:xfrm>
-            <a:off x="457200" y="1143000"/>
-            <a:ext cx="4023360" cy="1417320"/>
+            <a:off x="5943600" y="1463040"/>
+            <a:ext cx="420624" cy="420624"/>
           </a:xfrm>
           <a:prstGeom prst="rect">
             <a:avLst/>
           </a:prstGeom>
           <a:solidFill>
-            <a:srgbClr val="F2F2F2"/>
+            <a:srgbClr val="FFFFFF"/>
           </a:solidFill>
-          <a:ln w="12700">
+          <a:ln w="9525">
             <a:solidFill>
               <a:srgbClr val="C9CEDB"/>
             </a:solidFill>
@@ -8028,100 +8072,22 @@
       </p:sp>
       <p:sp>
         <p:nvSpPr>
-          <p:cNvPr id="4" name="Text 2"/>
-          <p:cNvSpPr txBox="1"/>
-          <p:nvPr/>
-        </p:nvSpPr>
-        <p:spPr>
-          <a:xfrm>
-            <a:off x="621792" y="1252728"/>
-            <a:ext cx="3694176" cy="274320"/>
-          </a:xfrm>
-          <a:prstGeom prst="rect">
-            <a:avLst/>
-          </a:prstGeom>
-          <a:noFill/>
-          <a:ln/>
-        </p:spPr>
-        <p:txBody>
-          <a:bodyPr wrap="square" lIns="0" tIns="0" rIns="0" bIns="0" rtlCol="0" anchor="ctr"/>
-          <a:lstStyle/>
-          <a:p>
-            <a:pPr indent="0" marL="0">
-              <a:buNone/>
-            </a:pPr>
-            <a:r>
-              <a:rPr lang="en-US" sz="1500" b="1" dirty="0">
-                <a:solidFill>
-                  <a:srgbClr val="1E2761"/>
-                </a:solidFill>
-                <a:latin typeface="Calibri" pitchFamily="34" charset="0"/>
-                <a:ea typeface="Calibri" pitchFamily="34" charset="-122"/>
-                <a:cs typeface="Calibri" pitchFamily="34" charset="-120"/>
-              </a:rPr>
-              <a:t>Custo de criação</a:t>
-            </a:r>
-            <a:endParaRPr lang="en-US" sz="1500" dirty="0"/>
-          </a:p>
-        </p:txBody>
-      </p:sp>
-      <p:sp>
-        <p:nvSpPr>
-          <p:cNvPr id="5" name="Text 3"/>
-          <p:cNvSpPr txBox="1"/>
-          <p:nvPr/>
-        </p:nvSpPr>
-        <p:spPr>
-          <a:xfrm>
-            <a:off x="621792" y="1581912"/>
-            <a:ext cx="3694176" cy="868680"/>
-          </a:xfrm>
-          <a:prstGeom prst="rect">
-            <a:avLst/>
-          </a:prstGeom>
-          <a:noFill/>
-          <a:ln/>
-        </p:spPr>
-        <p:txBody>
-          <a:bodyPr wrap="square" lIns="0" tIns="0" rIns="0" bIns="0" rtlCol="0" anchor="t"/>
-          <a:lstStyle/>
-          <a:p>
-            <a:pPr indent="0" marL="0">
-              <a:buNone/>
-            </a:pPr>
-            <a:r>
-              <a:rPr lang="en-US" sz="1300" dirty="0">
-                <a:solidFill>
-                  <a:srgbClr val="212121"/>
-                </a:solidFill>
-                <a:latin typeface="Calibri" pitchFamily="34" charset="0"/>
-                <a:ea typeface="Calibri" pitchFamily="34" charset="-122"/>
-                <a:cs typeface="Calibri" pitchFamily="34" charset="-120"/>
-              </a:rPr>
-              <a:t>A medição do material da disciplina: fork() custa cerca de 4x mais que pthread_create(), porque exige montar uma nova tabela de páginas.</a:t>
-            </a:r>
-            <a:endParaRPr lang="en-US" sz="1300" dirty="0"/>
-          </a:p>
-        </p:txBody>
-      </p:sp>
-      <p:sp>
-        <p:nvSpPr>
-          <p:cNvPr id="6" name="Shape 4"/>
+          <p:cNvPr id="5" name="Shape 3"/>
           <p:cNvSpPr/>
           <p:nvPr/>
         </p:nvSpPr>
         <p:spPr>
           <a:xfrm>
-            <a:off x="4663440" y="1143000"/>
-            <a:ext cx="4023360" cy="1417320"/>
+            <a:off x="6364224" y="1463040"/>
+            <a:ext cx="420624" cy="420624"/>
           </a:xfrm>
           <a:prstGeom prst="rect">
             <a:avLst/>
           </a:prstGeom>
           <a:solidFill>
-            <a:srgbClr val="F2F2F2"/>
+            <a:srgbClr val="97BC62"/>
           </a:solidFill>
-          <a:ln w="12700">
+          <a:ln w="9525">
             <a:solidFill>
               <a:srgbClr val="C9CEDB"/>
             </a:solidFill>
@@ -8131,100 +8097,22 @@
       </p:sp>
       <p:sp>
         <p:nvSpPr>
-          <p:cNvPr id="7" name="Text 5"/>
-          <p:cNvSpPr txBox="1"/>
-          <p:nvPr/>
-        </p:nvSpPr>
-        <p:spPr>
-          <a:xfrm>
-            <a:off x="4828032" y="1252728"/>
-            <a:ext cx="3694176" cy="274320"/>
-          </a:xfrm>
-          <a:prstGeom prst="rect">
-            <a:avLst/>
-          </a:prstGeom>
-          <a:noFill/>
-          <a:ln/>
-        </p:spPr>
-        <p:txBody>
-          <a:bodyPr wrap="square" lIns="0" tIns="0" rIns="0" bIns="0" rtlCol="0" anchor="ctr"/>
-          <a:lstStyle/>
-          <a:p>
-            <a:pPr indent="0" marL="0">
-              <a:buNone/>
-            </a:pPr>
-            <a:r>
-              <a:rPr lang="en-US" sz="1500" b="1" dirty="0">
-                <a:solidFill>
-                  <a:srgbClr val="1E2761"/>
-                </a:solidFill>
-                <a:latin typeface="Calibri" pitchFamily="34" charset="0"/>
-                <a:ea typeface="Calibri" pitchFamily="34" charset="-122"/>
-                <a:cs typeface="Calibri" pitchFamily="34" charset="-120"/>
-              </a:rPr>
-              <a:t>Natureza dos dados</a:t>
-            </a:r>
-            <a:endParaRPr lang="en-US" sz="1500" dirty="0"/>
-          </a:p>
-        </p:txBody>
-      </p:sp>
-      <p:sp>
-        <p:nvSpPr>
-          <p:cNvPr id="8" name="Text 6"/>
-          <p:cNvSpPr txBox="1"/>
-          <p:nvPr/>
-        </p:nvSpPr>
-        <p:spPr>
-          <a:xfrm>
-            <a:off x="4828032" y="1581912"/>
-            <a:ext cx="3694176" cy="868680"/>
-          </a:xfrm>
-          <a:prstGeom prst="rect">
-            <a:avLst/>
-          </a:prstGeom>
-          <a:noFill/>
-          <a:ln/>
-        </p:spPr>
-        <p:txBody>
-          <a:bodyPr wrap="square" lIns="0" tIns="0" rIns="0" bIns="0" rtlCol="0" anchor="t"/>
-          <a:lstStyle/>
-          <a:p>
-            <a:pPr indent="0" marL="0">
-              <a:buNone/>
-            </a:pPr>
-            <a:r>
-              <a:rPr lang="en-US" sz="1300" dirty="0">
-                <a:solidFill>
-                  <a:srgbClr val="212121"/>
-                </a:solidFill>
-                <a:latin typeface="Calibri" pitchFamily="34" charset="0"/>
-                <a:ea typeface="Calibri" pitchFamily="34" charset="-122"/>
-                <a:cs typeface="Calibri" pitchFamily="34" charset="-120"/>
-              </a:rPr>
-              <a:t>A matriz e o vetor de rótulos são grandes e precisam ser vistos por todos. Com threads eles já são compartilhados.</a:t>
-            </a:r>
-            <a:endParaRPr lang="en-US" sz="1300" dirty="0"/>
-          </a:p>
-        </p:txBody>
-      </p:sp>
-      <p:sp>
-        <p:nvSpPr>
-          <p:cNvPr id="9" name="Shape 7"/>
+          <p:cNvPr id="6" name="Shape 4"/>
           <p:cNvSpPr/>
           <p:nvPr/>
         </p:nvSpPr>
         <p:spPr>
           <a:xfrm>
-            <a:off x="457200" y="2743200"/>
-            <a:ext cx="4023360" cy="1280160"/>
+            <a:off x="6784848" y="1463040"/>
+            <a:ext cx="420624" cy="420624"/>
           </a:xfrm>
           <a:prstGeom prst="rect">
             <a:avLst/>
           </a:prstGeom>
           <a:solidFill>
-            <a:srgbClr val="F2F2F2"/>
+            <a:srgbClr val="97BC62"/>
           </a:solidFill>
-          <a:ln w="12700">
+          <a:ln w="9525">
             <a:solidFill>
               <a:srgbClr val="C9CEDB"/>
             </a:solidFill>
@@ -8234,100 +8122,22 @@
       </p:sp>
       <p:sp>
         <p:nvSpPr>
-          <p:cNvPr id="10" name="Text 8"/>
-          <p:cNvSpPr txBox="1"/>
-          <p:nvPr/>
-        </p:nvSpPr>
-        <p:spPr>
-          <a:xfrm>
-            <a:off x="621792" y="2852928"/>
-            <a:ext cx="3694176" cy="274320"/>
-          </a:xfrm>
-          <a:prstGeom prst="rect">
-            <a:avLst/>
-          </a:prstGeom>
-          <a:noFill/>
-          <a:ln/>
-        </p:spPr>
-        <p:txBody>
-          <a:bodyPr wrap="square" lIns="0" tIns="0" rIns="0" bIns="0" rtlCol="0" anchor="ctr"/>
-          <a:lstStyle/>
-          <a:p>
-            <a:pPr indent="0" marL="0">
-              <a:buNone/>
-            </a:pPr>
-            <a:r>
-              <a:rPr lang="en-US" sz="1500" b="1" dirty="0">
-                <a:solidFill>
-                  <a:srgbClr val="1E2761"/>
-                </a:solidFill>
-                <a:latin typeface="Calibri" pitchFamily="34" charset="0"/>
-                <a:ea typeface="Calibri" pitchFamily="34" charset="-122"/>
-                <a:cs typeface="Calibri" pitchFamily="34" charset="-120"/>
-              </a:rPr>
-              <a:t>Com processos seria preciso</a:t>
-            </a:r>
-            <a:endParaRPr lang="en-US" sz="1500" dirty="0"/>
-          </a:p>
-        </p:txBody>
-      </p:sp>
-      <p:sp>
-        <p:nvSpPr>
-          <p:cNvPr id="11" name="Text 9"/>
-          <p:cNvSpPr txBox="1"/>
-          <p:nvPr/>
-        </p:nvSpPr>
-        <p:spPr>
-          <a:xfrm>
-            <a:off x="621792" y="3182112"/>
-            <a:ext cx="3694176" cy="731520"/>
-          </a:xfrm>
-          <a:prstGeom prst="rect">
-            <a:avLst/>
-          </a:prstGeom>
-          <a:noFill/>
-          <a:ln/>
-        </p:spPr>
-        <p:txBody>
-          <a:bodyPr wrap="square" lIns="0" tIns="0" rIns="0" bIns="0" rtlCol="0" anchor="t"/>
-          <a:lstStyle/>
-          <a:p>
-            <a:pPr indent="0" marL="0">
-              <a:buNone/>
-            </a:pPr>
-            <a:r>
-              <a:rPr lang="en-US" sz="1300" dirty="0">
-                <a:solidFill>
-                  <a:srgbClr val="212121"/>
-                </a:solidFill>
-                <a:latin typeface="Calibri" pitchFamily="34" charset="0"/>
-                <a:ea typeface="Calibri" pitchFamily="34" charset="-122"/>
-                <a:cs typeface="Calibri" pitchFamily="34" charset="-120"/>
-              </a:rPr>
-              <a:t>shm_open mais mmap, ou devolver resultados parciais por pipes: mais código, sem mais paralelismo.</a:t>
-            </a:r>
-            <a:endParaRPr lang="en-US" sz="1300" dirty="0"/>
-          </a:p>
-        </p:txBody>
-      </p:sp>
-      <p:sp>
-        <p:nvSpPr>
-          <p:cNvPr id="12" name="Shape 10"/>
+          <p:cNvPr id="7" name="Shape 5"/>
           <p:cNvSpPr/>
           <p:nvPr/>
         </p:nvSpPr>
         <p:spPr>
           <a:xfrm>
-            <a:off x="4663440" y="2743200"/>
-            <a:ext cx="4023360" cy="1280160"/>
+            <a:off x="7205472" y="1463040"/>
+            <a:ext cx="420624" cy="420624"/>
           </a:xfrm>
           <a:prstGeom prst="rect">
             <a:avLst/>
           </a:prstGeom>
           <a:solidFill>
-            <a:srgbClr val="F2F2F2"/>
+            <a:srgbClr val="97BC62"/>
           </a:solidFill>
-          <a:ln w="12700">
+          <a:ln w="9525">
             <a:solidFill>
               <a:srgbClr val="C9CEDB"/>
             </a:solidFill>
@@ -8337,14 +8147,187 @@
       </p:sp>
       <p:sp>
         <p:nvSpPr>
-          <p:cNvPr id="13" name="Text 11"/>
+          <p:cNvPr id="8" name="Shape 6"/>
+          <p:cNvSpPr/>
+          <p:nvPr/>
+        </p:nvSpPr>
+        <p:spPr>
+          <a:xfrm>
+            <a:off x="7626096" y="1463040"/>
+            <a:ext cx="420624" cy="420624"/>
+          </a:xfrm>
+          <a:prstGeom prst="rect">
+            <a:avLst/>
+          </a:prstGeom>
+          <a:solidFill>
+            <a:srgbClr val="FFFFFF"/>
+          </a:solidFill>
+          <a:ln w="9525">
+            <a:solidFill>
+              <a:srgbClr val="C9CEDB"/>
+            </a:solidFill>
+            <a:prstDash val="solid"/>
+          </a:ln>
+        </p:spPr>
+      </p:sp>
+      <p:sp>
+        <p:nvSpPr>
+          <p:cNvPr id="9" name="Shape 7"/>
+          <p:cNvSpPr/>
+          <p:nvPr/>
+        </p:nvSpPr>
+        <p:spPr>
+          <a:xfrm>
+            <a:off x="5943600" y="1883664"/>
+            <a:ext cx="420624" cy="420624"/>
+          </a:xfrm>
+          <a:prstGeom prst="rect">
+            <a:avLst/>
+          </a:prstGeom>
+          <a:solidFill>
+            <a:srgbClr val="FFFFFF"/>
+          </a:solidFill>
+          <a:ln w="9525">
+            <a:solidFill>
+              <a:srgbClr val="C9CEDB"/>
+            </a:solidFill>
+            <a:prstDash val="solid"/>
+          </a:ln>
+        </p:spPr>
+      </p:sp>
+      <p:sp>
+        <p:nvSpPr>
+          <p:cNvPr id="10" name="Shape 8"/>
+          <p:cNvSpPr/>
+          <p:nvPr/>
+        </p:nvSpPr>
+        <p:spPr>
+          <a:xfrm>
+            <a:off x="6364224" y="1883664"/>
+            <a:ext cx="420624" cy="420624"/>
+          </a:xfrm>
+          <a:prstGeom prst="rect">
+            <a:avLst/>
+          </a:prstGeom>
+          <a:solidFill>
+            <a:srgbClr val="FFFFFF"/>
+          </a:solidFill>
+          <a:ln w="9525">
+            <a:solidFill>
+              <a:srgbClr val="C9CEDB"/>
+            </a:solidFill>
+            <a:prstDash val="solid"/>
+          </a:ln>
+        </p:spPr>
+      </p:sp>
+      <p:sp>
+        <p:nvSpPr>
+          <p:cNvPr id="11" name="Shape 9"/>
+          <p:cNvSpPr/>
+          <p:nvPr/>
+        </p:nvSpPr>
+        <p:spPr>
+          <a:xfrm>
+            <a:off x="6784848" y="1883664"/>
+            <a:ext cx="420624" cy="420624"/>
+          </a:xfrm>
+          <a:prstGeom prst="rect">
+            <a:avLst/>
+          </a:prstGeom>
+          <a:solidFill>
+            <a:srgbClr val="1E2761"/>
+          </a:solidFill>
+          <a:ln w="9525">
+            <a:solidFill>
+              <a:srgbClr val="C9CEDB"/>
+            </a:solidFill>
+            <a:prstDash val="solid"/>
+          </a:ln>
+        </p:spPr>
+      </p:sp>
+      <p:sp>
+        <p:nvSpPr>
+          <p:cNvPr id="12" name="Shape 10"/>
+          <p:cNvSpPr/>
+          <p:nvPr/>
+        </p:nvSpPr>
+        <p:spPr>
+          <a:xfrm>
+            <a:off x="7205472" y="1883664"/>
+            <a:ext cx="420624" cy="420624"/>
+          </a:xfrm>
+          <a:prstGeom prst="rect">
+            <a:avLst/>
+          </a:prstGeom>
+          <a:solidFill>
+            <a:srgbClr val="FFFFFF"/>
+          </a:solidFill>
+          <a:ln w="9525">
+            <a:solidFill>
+              <a:srgbClr val="C9CEDB"/>
+            </a:solidFill>
+            <a:prstDash val="solid"/>
+          </a:ln>
+        </p:spPr>
+      </p:sp>
+      <p:sp>
+        <p:nvSpPr>
+          <p:cNvPr id="13" name="Shape 11"/>
+          <p:cNvSpPr/>
+          <p:nvPr/>
+        </p:nvSpPr>
+        <p:spPr>
+          <a:xfrm>
+            <a:off x="7626096" y="1883664"/>
+            <a:ext cx="420624" cy="420624"/>
+          </a:xfrm>
+          <a:prstGeom prst="rect">
+            <a:avLst/>
+          </a:prstGeom>
+          <a:solidFill>
+            <a:srgbClr val="FFFFFF"/>
+          </a:solidFill>
+          <a:ln w="9525">
+            <a:solidFill>
+              <a:srgbClr val="C9CEDB"/>
+            </a:solidFill>
+            <a:prstDash val="solid"/>
+          </a:ln>
+        </p:spPr>
+      </p:sp>
+      <p:sp>
+        <p:nvSpPr>
+          <p:cNvPr id="14" name="Shape 12"/>
+          <p:cNvSpPr/>
+          <p:nvPr/>
+        </p:nvSpPr>
+        <p:spPr>
+          <a:xfrm>
+            <a:off x="5852160" y="1883664"/>
+            <a:ext cx="2286000" cy="0"/>
+          </a:xfrm>
+          <a:prstGeom prst="line">
+            <a:avLst/>
+          </a:prstGeom>
+          <a:noFill/>
+          <a:ln w="25400">
+            <a:solidFill>
+              <a:srgbClr val="B85042"/>
+            </a:solidFill>
+            <a:prstDash val="dash"/>
+          </a:ln>
+        </p:spPr>
+      </p:sp>
+      <p:sp>
+        <p:nvSpPr>
+          <p:cNvPr id="15" name="Text 13"/>
           <p:cNvSpPr txBox="1"/>
           <p:nvPr/>
         </p:nvSpPr>
         <p:spPr>
           <a:xfrm>
-            <a:off x="4828032" y="2852928"/>
-            <a:ext cx="3694176" cy="274320"/>
+            <a:off x="5394960" y="2423160"/>
+            <a:ext cx="3291840" cy="274320"/>
           </a:xfrm>
           <a:prstGeom prst="rect">
             <a:avLst/>
@@ -8356,73 +8339,34 @@
           <a:bodyPr wrap="square" lIns="0" tIns="0" rIns="0" bIns="0" rtlCol="0" anchor="ctr"/>
           <a:lstStyle/>
           <a:p>
-            <a:pPr indent="0" marL="0">
+            <a:pPr algn="ctr" indent="0" marL="0">
               <a:buNone/>
             </a:pPr>
             <a:r>
-              <a:rPr lang="en-US" sz="1500" b="1" dirty="0">
-                <a:solidFill>
-                  <a:srgbClr val="1E2761"/>
-                </a:solidFill>
-                <a:latin typeface="Calibri" pitchFamily="34" charset="0"/>
-                <a:ea typeface="Calibri" pitchFamily="34" charset="-122"/>
-                <a:cs typeface="Calibri" pitchFamily="34" charset="-120"/>
-              </a:rPr>
-              <a:t>Cuidado conhecido</a:t>
-            </a:r>
-            <a:endParaRPr lang="en-US" sz="1500" dirty="0"/>
+              <a:rPr lang="en-US" sz="1200" dirty="0">
+                <a:solidFill>
+                  <a:srgbClr val="5A5A5A"/>
+                </a:solidFill>
+                <a:latin typeface="Calibri" pitchFamily="34" charset="0"/>
+                <a:ea typeface="Calibri" pitchFamily="34" charset="-122"/>
+                <a:cs typeface="Calibri" pitchFamily="34" charset="-120"/>
+              </a:rPr>
+              <a:t>fronteira entre duas faixas</a:t>
+            </a:r>
+            <a:endParaRPr lang="en-US" sz="1200" dirty="0"/>
           </a:p>
         </p:txBody>
       </p:sp>
       <p:sp>
         <p:nvSpPr>
-          <p:cNvPr id="14" name="Text 12"/>
+          <p:cNvPr id="16" name="Text 14"/>
           <p:cNvSpPr txBox="1"/>
           <p:nvPr/>
         </p:nvSpPr>
         <p:spPr>
           <a:xfrm>
-            <a:off x="4828032" y="3182112"/>
-            <a:ext cx="3694176" cy="731520"/>
-          </a:xfrm>
-          <a:prstGeom prst="rect">
-            <a:avLst/>
-          </a:prstGeom>
-          <a:noFill/>
-          <a:ln/>
-        </p:spPr>
-        <p:txBody>
-          <a:bodyPr wrap="square" lIns="0" tIns="0" rIns="0" bIns="0" rtlCol="0" anchor="t"/>
-          <a:lstStyle/>
-          <a:p>
-            <a:pPr indent="0" marL="0">
-              <a:buNone/>
-            </a:pPr>
-            <a:r>
-              <a:rPr lang="en-US" sz="1300" dirty="0">
-                <a:solidFill>
-                  <a:srgbClr val="212121"/>
-                </a:solidFill>
-                <a:latin typeface="Calibri" pitchFamily="34" charset="0"/>
-                <a:ea typeface="Calibri" pitchFamily="34" charset="-122"/>
-                <a:cs typeface="Calibri" pitchFamily="34" charset="-120"/>
-              </a:rPr>
-              <a:t>fork() depois de criar threads clona mutexes travados. Aqui não há mistura dos dois modelos.</a:t>
-            </a:r>
-            <a:endParaRPr lang="en-US" sz="1300" dirty="0"/>
-          </a:p>
-        </p:txBody>
-      </p:sp>
-      <p:sp>
-        <p:nvSpPr>
-          <p:cNvPr id="15" name="Text 13"/>
-          <p:cNvSpPr txBox="1"/>
-          <p:nvPr/>
-        </p:nvSpPr>
-        <p:spPr>
-          <a:xfrm>
-            <a:off x="457200" y="4709160"/>
-            <a:ext cx="5486400" cy="274320"/>
+            <a:off x="5394960" y="2743200"/>
+            <a:ext cx="3291840" cy="548640"/>
           </a:xfrm>
           <a:prstGeom prst="rect">
             <a:avLst/>
@@ -8434,6 +8378,62 @@
           <a:bodyPr wrap="square" lIns="0" tIns="0" rIns="0" bIns="0" rtlCol="0" anchor="ctr"/>
           <a:lstStyle/>
           <a:p>
+            <a:pPr algn="ctr" indent="0" marL="0">
+              <a:buNone/>
+            </a:pPr>
+            <a:r>
+              <a:rPr lang="en-US" sz="1200" dirty="0">
+                <a:solidFill>
+                  <a:srgbClr val="212121"/>
+                </a:solidFill>
+                <a:latin typeface="Calibri" pitchFamily="34" charset="0"/>
+                <a:ea typeface="Calibri" pitchFamily="34" charset="-122"/>
+                <a:cs typeface="Calibri" pitchFamily="34" charset="-120"/>
+              </a:rPr>
+              <a:t>os três vizinhos cobrem a vertical</a:t>
+            </a:r>
+            <a:endParaRPr lang="en-US" sz="1200" dirty="0"/>
+          </a:p>
+          <a:p>
+            <a:pPr algn="ctr" indent="0" marL="0">
+              <a:buNone/>
+            </a:pPr>
+            <a:r>
+              <a:rPr lang="en-US" sz="1200" dirty="0">
+                <a:solidFill>
+                  <a:srgbClr val="212121"/>
+                </a:solidFill>
+                <a:latin typeface="Calibri" pitchFamily="34" charset="0"/>
+                <a:ea typeface="Calibri" pitchFamily="34" charset="-122"/>
+                <a:cs typeface="Calibri" pitchFamily="34" charset="-120"/>
+              </a:rPr>
+              <a:t>e as duas diagonais</a:t>
+            </a:r>
+            <a:endParaRPr lang="en-US" sz="1200" dirty="0"/>
+          </a:p>
+        </p:txBody>
+      </p:sp>
+      <p:sp>
+        <p:nvSpPr>
+          <p:cNvPr id="17" name="Text 15"/>
+          <p:cNvSpPr txBox="1"/>
+          <p:nvPr/>
+        </p:nvSpPr>
+        <p:spPr>
+          <a:xfrm>
+            <a:off x="457200" y="4709160"/>
+            <a:ext cx="5486400" cy="274320"/>
+          </a:xfrm>
+          <a:prstGeom prst="rect">
+            <a:avLst/>
+          </a:prstGeom>
+          <a:noFill/>
+          <a:ln/>
+        </p:spPr>
+        <p:txBody>
+          <a:bodyPr wrap="square" lIns="0" tIns="0" rIns="0" bIns="0" rtlCol="0" anchor="ctr"/>
+          <a:lstStyle/>
+          <a:p>
             <a:pPr indent="0" marL="0">
               <a:buNone/>
             </a:pPr>
@@ -8454,7 +8454,7 @@
       </p:sp>
       <p:sp>
         <p:nvSpPr>
-          <p:cNvPr id="16" name="Text 14"/>
+          <p:cNvPr id="18" name="Text 16"/>
           <p:cNvSpPr txBox="1"/>
           <p:nvPr/>
         </p:nvSpPr>

</xml_diff>